<commit_message>
Rework natural resource assessment slide using external methodology sources
Co-Authored-By: Claude Sonnet 5.5 <noreply@anthropic.com>
Claude-Session: https://claude.ai/code/session_01PfagTkBBfn3ShTm5bX9M45
</commit_message>
<xml_diff>
--- a/slide_otsenka_prirodno_resursnogo_potentsiala.pptx
+++ b/slide_otsenka_prirodno_resursnogo_potentsiala.pptx
@@ -430,7 +430,7 @@
           <a:lstStyle/>
           <a:p>
             <a:r>
-              <a:t>Слайд составлен по слайду «Природно-ресурсный потенциал сельской территории» (компоненты, что оценивать) и таблице природных факторов. Трёхуровневая шкала (высокий, средний, низкий) и шаги оценки предложены при оформлении, пороговых значений нет, оценка идёт относительно региона и района того же типа. Колонка «Высокий уровень» написана при оформлении и требует сверки. В последнюю строку добавлены опасные явления из таблицы природных факторов.</a:t>
+              <a:t>Слайд составлен по внешним источникам, а не по материалам презентации. Агроклиматический потенциал в баллах от 5 до 100 по сумме температур выше +10 °С и осадкам взят из методики оценки агроландшафтов России (jbks.ru). Бонитировка почв с эталоном 100 баллов у чернозёма описана в материалах КГАУ, балло-гектары (площадь пашни на средневзвешенный балл) в работе БГУ. Ранговая шкала 0–100 по запасу ресурса на единицу площади взята из бюллетеня ИнЭкА. Для лесного, водного, минерально-сырьевого и рекреационного компонентов отдельных балльных шкал найти не удалось, поэтому для них указан запас на единицу площади. Веса и состав индекса условны, их согласуют с заказчиком.</a:t>
             </a:r>
           </a:p>
         </p:txBody>
@@ -6289,7 +6289,7 @@
                 </a:solidFill>
                 <a:latin typeface="Circe"/>
               </a:rPr>
-              <a:t>Показатели каждого компонента сравниваются со средним по региону и с районами того же типа</a:t>
+              <a:t>Каждый компонент оценивается своей балльной шкалой, затем баллы сводятся в интегральный индекс</a:t>
             </a:r>
             <a:endParaRPr sz="2200" b="0" dirty="0">
               <a:solidFill>
@@ -6344,7 +6344,7 @@
         <p:spPr>
           <a:xfrm>
             <a:off x="4114800" y="2331720"/>
-            <a:ext cx="4206240" cy="365760"/>
+            <a:ext cx="5120640" cy="365760"/>
           </a:xfrm>
           <a:prstGeom prst="rect">
             <a:avLst/>
@@ -6365,7 +6365,7 @@
                 </a:solidFill>
                 <a:latin typeface="Circe Bold"/>
               </a:rPr>
-              <a:t>ПОКАЗАТЕЛИ</a:t>
+              <a:t>КАК ОЦЕНИВАЮТ</a:t>
             </a:r>
           </a:p>
         </p:txBody>
@@ -6378,8 +6378,8 @@
         </p:nvSpPr>
         <p:spPr>
           <a:xfrm>
-            <a:off x="8503920" y="2331720"/>
-            <a:ext cx="3017520" cy="365760"/>
+            <a:off x="9418320" y="2331720"/>
+            <a:ext cx="2377440" cy="365760"/>
           </a:xfrm>
           <a:prstGeom prst="rect">
             <a:avLst/>
@@ -6400,7 +6400,7 @@
                 </a:solidFill>
                 <a:latin typeface="Circe Bold"/>
               </a:rPr>
-              <a:t>ВЫСОКИЙ УРОВЕНЬ</a:t>
+              <a:t>РЕЗУЛЬТАТ</a:t>
             </a:r>
           </a:p>
         </p:txBody>
@@ -6414,7 +6414,7 @@
         <p:spPr>
           <a:xfrm>
             <a:off x="1069848" y="2788920"/>
-            <a:ext cx="10607040" cy="0"/>
+            <a:ext cx="10881360" cy="0"/>
           </a:xfrm>
           <a:prstGeom prst="line">
             <a:avLst/>
@@ -6435,7 +6435,7 @@
         <p:spPr>
           <a:xfrm>
             <a:off x="1069848" y="2862072"/>
-            <a:ext cx="10607040" cy="914400"/>
+            <a:ext cx="10881360" cy="1051560"/>
           </a:xfrm>
           <a:prstGeom prst="rect">
             <a:avLst/>
@@ -6464,7 +6464,7 @@
         <p:spPr>
           <a:xfrm>
             <a:off x="1280160" y="2862072"/>
-            <a:ext cx="2651760" cy="914400"/>
+            <a:ext cx="2651760" cy="1051560"/>
           </a:xfrm>
           <a:prstGeom prst="rect">
             <a:avLst/>
@@ -6479,7 +6479,7 @@
           <a:p>
             <a:pPr algn="l"/>
             <a:r>
-              <a:rPr sz="1700" b="1">
+              <a:rPr sz="1600" b="1">
                 <a:solidFill>
                   <a:srgbClr val="062D3F"/>
                 </a:solidFill>
@@ -6492,14 +6492,14 @@
       </p:sp>
       <p:sp>
         <p:nvSpPr>
-          <p:cNvPr id="209" name="Показатели"/>
+          <p:cNvPr id="209" name="Как оценивают"/>
           <p:cNvSpPr txBox="1"/>
           <p:nvPr/>
         </p:nvSpPr>
         <p:spPr>
           <a:xfrm>
             <a:off x="4114800" y="2862072"/>
-            <a:ext cx="4206240" cy="914400"/>
+            <a:ext cx="5120640" cy="1051560"/>
           </a:xfrm>
           <a:prstGeom prst="rect">
             <a:avLst/>
@@ -6520,21 +6520,21 @@
                 </a:solidFill>
                 <a:latin typeface="Circe"/>
               </a:rPr>
-              <a:t>Биоклиматический потенциал, сумма температур выше +10 °С, гидротермический коэффициент</a:t>
+              <a:t>Сумму температур выше +10 °С и годовые осадки переводят в баллы от 5 до 100</a:t>
             </a:r>
           </a:p>
         </p:txBody>
       </p:sp>
       <p:sp>
         <p:nvSpPr>
-          <p:cNvPr id="210" name="Высокий уровень"/>
+          <p:cNvPr id="210" name="Результат"/>
           <p:cNvSpPr txBox="1"/>
           <p:nvPr/>
         </p:nvSpPr>
         <p:spPr>
           <a:xfrm>
-            <a:off x="8503920" y="2862072"/>
-            <a:ext cx="3017520" cy="914400"/>
+            <a:off x="9418320" y="2862072"/>
+            <a:ext cx="2377440" cy="1051560"/>
           </a:xfrm>
           <a:prstGeom prst="rect">
             <a:avLst/>
@@ -6555,7 +6555,7 @@
                 </a:solidFill>
                 <a:latin typeface="Circe"/>
               </a:rPr>
-              <a:t>Достаточно тепла и влаги для возделывания культур</a:t>
+              <a:t>Балл агроклиматического потенциала</a:t>
             </a:r>
           </a:p>
         </p:txBody>
@@ -6568,8 +6568,8 @@
         </p:nvSpPr>
         <p:spPr>
           <a:xfrm>
-            <a:off x="1280160" y="3776472"/>
-            <a:ext cx="2651760" cy="914400"/>
+            <a:off x="1280160" y="3913631"/>
+            <a:ext cx="2651760" cy="1828800"/>
           </a:xfrm>
           <a:prstGeom prst="rect">
             <a:avLst/>
@@ -6584,7 +6584,7 @@
           <a:p>
             <a:pPr algn="l"/>
             <a:r>
-              <a:rPr sz="1700" b="1">
+              <a:rPr sz="1600" b="1">
                 <a:solidFill>
                   <a:srgbClr val="062D3F"/>
                 </a:solidFill>
@@ -6597,14 +6597,14 @@
       </p:sp>
       <p:sp>
         <p:nvSpPr>
-          <p:cNvPr id="212" name="Показатели"/>
+          <p:cNvPr id="212" name="Как оценивают"/>
           <p:cNvSpPr txBox="1"/>
           <p:nvPr/>
         </p:nvSpPr>
         <p:spPr>
           <a:xfrm>
-            <a:off x="4114800" y="3776472"/>
-            <a:ext cx="4206240" cy="914400"/>
+            <a:off x="4114800" y="3913631"/>
+            <a:ext cx="5120640" cy="1828800"/>
           </a:xfrm>
           <a:prstGeom prst="rect">
             <a:avLst/>
@@ -6625,21 +6625,21 @@
                 </a:solidFill>
                 <a:latin typeface="Circe"/>
               </a:rPr>
-              <a:t>Доля сельхозугодий и пашни, доля залежей, содержание гумуса в пахотном слое</a:t>
+              <a:t>Бонитировка почв. Эталоном в 100 баллов служит обыкновенный чернозём, оценка идёт по мощности гумусового горизонта и запасам гумуса. Площадь пашни умножают на средневзвешенный балл</a:t>
             </a:r>
           </a:p>
         </p:txBody>
       </p:sp>
       <p:sp>
         <p:nvSpPr>
-          <p:cNvPr id="213" name="Высокий уровень"/>
+          <p:cNvPr id="213" name="Результат"/>
           <p:cNvSpPr txBox="1"/>
           <p:nvPr/>
         </p:nvSpPr>
         <p:spPr>
           <a:xfrm>
-            <a:off x="8503920" y="3776472"/>
-            <a:ext cx="3017520" cy="914400"/>
+            <a:off x="9418320" y="3913631"/>
+            <a:ext cx="2377440" cy="1828800"/>
           </a:xfrm>
           <a:prstGeom prst="rect">
             <a:avLst/>
@@ -6660,7 +6660,7 @@
                 </a:solidFill>
                 <a:latin typeface="Circe"/>
               </a:rPr>
-              <a:t>Много качественных земель в обороте, мало залежей</a:t>
+              <a:t>Балл бонитета и балло-гектары</a:t>
             </a:r>
           </a:p>
         </p:txBody>
@@ -6673,8 +6673,8 @@
         </p:nvSpPr>
         <p:spPr>
           <a:xfrm>
-            <a:off x="1069848" y="4690872"/>
-            <a:ext cx="10607040" cy="914400"/>
+            <a:off x="1069848" y="5742431"/>
+            <a:ext cx="10881360" cy="1371600"/>
           </a:xfrm>
           <a:prstGeom prst="rect">
             <a:avLst/>
@@ -6702,8 +6702,8 @@
         </p:nvSpPr>
         <p:spPr>
           <a:xfrm>
-            <a:off x="1280160" y="4690872"/>
-            <a:ext cx="2651760" cy="914400"/>
+            <a:off x="1280160" y="5742431"/>
+            <a:ext cx="2651760" cy="1371600"/>
           </a:xfrm>
           <a:prstGeom prst="rect">
             <a:avLst/>
@@ -6718,27 +6718,27 @@
           <a:p>
             <a:pPr algn="l"/>
             <a:r>
-              <a:rPr sz="1700" b="1">
+              <a:rPr sz="1600" b="1">
                 <a:solidFill>
                   <a:srgbClr val="062D3F"/>
                 </a:solidFill>
                 <a:latin typeface="Circe Bold"/>
               </a:rPr>
-              <a:t>Лесной</a:t>
+              <a:t>Лесной, водный, минерально-сырьевой, рекреационный</a:t>
             </a:r>
           </a:p>
         </p:txBody>
       </p:sp>
       <p:sp>
         <p:nvSpPr>
-          <p:cNvPr id="216" name="Показатели"/>
+          <p:cNvPr id="216" name="Как оценивают"/>
           <p:cNvSpPr txBox="1"/>
           <p:nvPr/>
         </p:nvSpPr>
         <p:spPr>
           <a:xfrm>
-            <a:off x="4114800" y="4690872"/>
-            <a:ext cx="4206240" cy="914400"/>
+            <a:off x="4114800" y="5742431"/>
+            <a:ext cx="5120640" cy="1371600"/>
           </a:xfrm>
           <a:prstGeom prst="rect">
             <a:avLst/>
@@ -6759,21 +6759,21 @@
                 </a:solidFill>
                 <a:latin typeface="Circe"/>
               </a:rPr>
-              <a:t>Лесистость, доля лесов и болот в площади района</a:t>
+              <a:t>Запас ресурса на единицу площади района</a:t>
             </a:r>
           </a:p>
         </p:txBody>
       </p:sp>
       <p:sp>
         <p:nvSpPr>
-          <p:cNvPr id="217" name="Высокий уровень"/>
+          <p:cNvPr id="217" name="Результат"/>
           <p:cNvSpPr txBox="1"/>
           <p:nvPr/>
         </p:nvSpPr>
         <p:spPr>
           <a:xfrm>
-            <a:off x="8503920" y="4690872"/>
-            <a:ext cx="3017520" cy="914400"/>
+            <a:off x="9418320" y="5742431"/>
+            <a:ext cx="2377440" cy="1371600"/>
           </a:xfrm>
           <a:prstGeom prst="rect">
             <a:avLst/>
@@ -6794,7 +6794,7 @@
                 </a:solidFill>
                 <a:latin typeface="Circe"/>
               </a:rPr>
-              <a:t>Лесистость отвечает специализации района</a:t>
+              <a:t>Значение на единицу площади</a:t>
             </a:r>
           </a:p>
         </p:txBody>
@@ -6807,8 +6807,8 @@
         </p:nvSpPr>
         <p:spPr>
           <a:xfrm>
-            <a:off x="1280160" y="5605272"/>
-            <a:ext cx="2651760" cy="914400"/>
+            <a:off x="1280160" y="7114031"/>
+            <a:ext cx="2651760" cy="1188720"/>
           </a:xfrm>
           <a:prstGeom prst="rect">
             <a:avLst/>
@@ -6823,27 +6823,27 @@
           <a:p>
             <a:pPr algn="l"/>
             <a:r>
-              <a:rPr sz="1700" b="1">
+              <a:rPr sz="1600" b="1">
                 <a:solidFill>
                   <a:srgbClr val="062D3F"/>
                 </a:solidFill>
                 <a:latin typeface="Circe Bold"/>
               </a:rPr>
-              <a:t>Водный</a:t>
+              <a:t>Нагрузка и деградация</a:t>
             </a:r>
           </a:p>
         </p:txBody>
       </p:sp>
       <p:sp>
         <p:nvSpPr>
-          <p:cNvPr id="219" name="Показатели"/>
+          <p:cNvPr id="219" name="Как оценивают"/>
           <p:cNvSpPr txBox="1"/>
           <p:nvPr/>
         </p:nvSpPr>
         <p:spPr>
           <a:xfrm>
-            <a:off x="4114800" y="5605272"/>
-            <a:ext cx="4206240" cy="914400"/>
+            <a:off x="4114800" y="7114031"/>
+            <a:ext cx="5120640" cy="1188720"/>
           </a:xfrm>
           <a:prstGeom prst="rect">
             <a:avLst/>
@@ -6864,21 +6864,21 @@
                 </a:solidFill>
                 <a:latin typeface="Circe"/>
               </a:rPr>
-              <a:t>Обеспеченность водными ресурсами, качество поверхностных и подземных вод</a:t>
+              <a:t>Выявляют лимитирующие факторы, например эрозию и низкое содержание калия в почве</a:t>
             </a:r>
           </a:p>
         </p:txBody>
       </p:sp>
       <p:sp>
         <p:nvSpPr>
-          <p:cNvPr id="220" name="Высокий уровень"/>
+          <p:cNvPr id="220" name="Результат"/>
           <p:cNvSpPr txBox="1"/>
           <p:nvPr/>
         </p:nvSpPr>
         <p:spPr>
           <a:xfrm>
-            <a:off x="8503920" y="5605272"/>
-            <a:ext cx="3017520" cy="914400"/>
+            <a:off x="9418320" y="7114031"/>
+            <a:ext cx="2377440" cy="1188720"/>
           </a:xfrm>
           <a:prstGeom prst="rect">
             <a:avLst/>
@@ -6899,394 +6899,21 @@
                 </a:solidFill>
                 <a:latin typeface="Circe"/>
               </a:rPr>
-              <a:t>Воды достаточно, качество соответствует нормам</a:t>
+              <a:t>Перечень ограничений</a:t>
             </a:r>
           </a:p>
         </p:txBody>
       </p:sp>
       <p:sp>
         <p:nvSpPr>
-          <p:cNvPr id="221" name="Полоса"/>
+          <p:cNvPr id="221" name="Шапка метода"/>
           <p:cNvSpPr/>
           <p:nvPr/>
         </p:nvSpPr>
         <p:spPr>
           <a:xfrm>
-            <a:off x="1069848" y="6519672"/>
-            <a:ext cx="10607040" cy="914400"/>
-          </a:xfrm>
-          <a:prstGeom prst="rect">
-            <a:avLst/>
-          </a:prstGeom>
-          <a:solidFill>
-            <a:srgbClr val="F2F4F5"/>
-          </a:solidFill>
-          <a:ln>
-            <a:noFill/>
-          </a:ln>
-        </p:spPr>
-        <p:txBody>
-          <a:bodyPr rtlCol="0" anchor="ctr"/>
-          <a:lstStyle/>
-          <a:p>
-            <a:pPr algn="ctr"/>
-          </a:p>
-        </p:txBody>
-      </p:sp>
-      <p:sp>
-        <p:nvSpPr>
-          <p:cNvPr id="222" name="Компонент"/>
-          <p:cNvSpPr txBox="1"/>
-          <p:nvPr/>
-        </p:nvSpPr>
-        <p:spPr>
-          <a:xfrm>
-            <a:off x="1280160" y="6519672"/>
-            <a:ext cx="2651760" cy="914400"/>
-          </a:xfrm>
-          <a:prstGeom prst="rect">
-            <a:avLst/>
-          </a:prstGeom>
-          <a:noFill/>
-        </p:spPr>
-        <p:txBody>
-          <a:bodyPr wrap="square" anchor="ctr" lIns="0" rIns="0" tIns="0" bIns="0">
-            <a:spAutoFit/>
-          </a:bodyPr>
-          <a:lstStyle/>
-          <a:p>
-            <a:pPr algn="l"/>
-            <a:r>
-              <a:rPr sz="1700" b="1">
-                <a:solidFill>
-                  <a:srgbClr val="062D3F"/>
-                </a:solidFill>
-                <a:latin typeface="Circe Bold"/>
-              </a:rPr>
-              <a:t>Минерально-сырьевой</a:t>
-            </a:r>
-          </a:p>
-        </p:txBody>
-      </p:sp>
-      <p:sp>
-        <p:nvSpPr>
-          <p:cNvPr id="223" name="Показатели"/>
-          <p:cNvSpPr txBox="1"/>
-          <p:nvPr/>
-        </p:nvSpPr>
-        <p:spPr>
-          <a:xfrm>
-            <a:off x="4114800" y="6519672"/>
-            <a:ext cx="4206240" cy="914400"/>
-          </a:xfrm>
-          <a:prstGeom prst="rect">
-            <a:avLst/>
-          </a:prstGeom>
-          <a:noFill/>
-        </p:spPr>
-        <p:txBody>
-          <a:bodyPr wrap="square" anchor="ctr" lIns="0" rIns="0" tIns="0" bIns="0">
-            <a:spAutoFit/>
-          </a:bodyPr>
-          <a:lstStyle/>
-          <a:p>
-            <a:pPr algn="l"/>
-            <a:r>
-              <a:rPr sz="1400" b="0">
-                <a:solidFill>
-                  <a:srgbClr val="062D3F"/>
-                </a:solidFill>
-                <a:latin typeface="Circe"/>
-              </a:rPr>
-              <a:t>Разведанные запасы, в первую очередь строительного сырья</a:t>
-            </a:r>
-          </a:p>
-        </p:txBody>
-      </p:sp>
-      <p:sp>
-        <p:nvSpPr>
-          <p:cNvPr id="224" name="Высокий уровень"/>
-          <p:cNvSpPr txBox="1"/>
-          <p:nvPr/>
-        </p:nvSpPr>
-        <p:spPr>
-          <a:xfrm>
-            <a:off x="8503920" y="6519672"/>
-            <a:ext cx="3017520" cy="914400"/>
-          </a:xfrm>
-          <a:prstGeom prst="rect">
-            <a:avLst/>
-          </a:prstGeom>
-          <a:noFill/>
-        </p:spPr>
-        <p:txBody>
-          <a:bodyPr wrap="square" anchor="ctr" lIns="0" rIns="0" tIns="0" bIns="0">
-            <a:spAutoFit/>
-          </a:bodyPr>
-          <a:lstStyle/>
-          <a:p>
-            <a:pPr algn="l"/>
-            <a:r>
-              <a:rPr sz="1400" b="0">
-                <a:solidFill>
-                  <a:srgbClr val="062D3F"/>
-                </a:solidFill>
-                <a:latin typeface="Circe"/>
-              </a:rPr>
-              <a:t>Есть разведанные запасы строительного сырья</a:t>
-            </a:r>
-          </a:p>
-        </p:txBody>
-      </p:sp>
-      <p:sp>
-        <p:nvSpPr>
-          <p:cNvPr id="225" name="Компонент"/>
-          <p:cNvSpPr txBox="1"/>
-          <p:nvPr/>
-        </p:nvSpPr>
-        <p:spPr>
-          <a:xfrm>
-            <a:off x="1280160" y="7434071"/>
-            <a:ext cx="2651760" cy="914400"/>
-          </a:xfrm>
-          <a:prstGeom prst="rect">
-            <a:avLst/>
-          </a:prstGeom>
-          <a:noFill/>
-        </p:spPr>
-        <p:txBody>
-          <a:bodyPr wrap="square" anchor="ctr" lIns="0" rIns="0" tIns="0" bIns="0">
-            <a:spAutoFit/>
-          </a:bodyPr>
-          <a:lstStyle/>
-          <a:p>
-            <a:pPr algn="l"/>
-            <a:r>
-              <a:rPr sz="1700" b="1">
-                <a:solidFill>
-                  <a:srgbClr val="062D3F"/>
-                </a:solidFill>
-                <a:latin typeface="Circe Bold"/>
-              </a:rPr>
-              <a:t>Рекреационный</a:t>
-            </a:r>
-          </a:p>
-        </p:txBody>
-      </p:sp>
-      <p:sp>
-        <p:nvSpPr>
-          <p:cNvPr id="226" name="Показатели"/>
-          <p:cNvSpPr txBox="1"/>
-          <p:nvPr/>
-        </p:nvSpPr>
-        <p:spPr>
-          <a:xfrm>
-            <a:off x="4114800" y="7434071"/>
-            <a:ext cx="4206240" cy="914400"/>
-          </a:xfrm>
-          <a:prstGeom prst="rect">
-            <a:avLst/>
-          </a:prstGeom>
-          <a:noFill/>
-        </p:spPr>
-        <p:txBody>
-          <a:bodyPr wrap="square" anchor="ctr" lIns="0" rIns="0" tIns="0" bIns="0">
-            <a:spAutoFit/>
-          </a:bodyPr>
-          <a:lstStyle/>
-          <a:p>
-            <a:pPr algn="l"/>
-            <a:r>
-              <a:rPr sz="1400" b="0">
-                <a:solidFill>
-                  <a:srgbClr val="062D3F"/>
-                </a:solidFill>
-                <a:latin typeface="Circe"/>
-              </a:rPr>
-              <a:t>Сочетание водоёмов, опушек леса и транспортной доступности</a:t>
-            </a:r>
-          </a:p>
-        </p:txBody>
-      </p:sp>
-      <p:sp>
-        <p:nvSpPr>
-          <p:cNvPr id="227" name="Высокий уровень"/>
-          <p:cNvSpPr txBox="1"/>
-          <p:nvPr/>
-        </p:nvSpPr>
-        <p:spPr>
-          <a:xfrm>
-            <a:off x="8503920" y="7434071"/>
-            <a:ext cx="3017520" cy="914400"/>
-          </a:xfrm>
-          <a:prstGeom prst="rect">
-            <a:avLst/>
-          </a:prstGeom>
-          <a:noFill/>
-        </p:spPr>
-        <p:txBody>
-          <a:bodyPr wrap="square" anchor="ctr" lIns="0" rIns="0" tIns="0" bIns="0">
-            <a:spAutoFit/>
-          </a:bodyPr>
-          <a:lstStyle/>
-          <a:p>
-            <a:pPr algn="l"/>
-            <a:r>
-              <a:rPr sz="1400" b="0">
-                <a:solidFill>
-                  <a:srgbClr val="062D3F"/>
-                </a:solidFill>
-                <a:latin typeface="Circe"/>
-              </a:rPr>
-              <a:t>Водоёмы и леса расположены рядом с дорогами</a:t>
-            </a:r>
-          </a:p>
-        </p:txBody>
-      </p:sp>
-      <p:sp>
-        <p:nvSpPr>
-          <p:cNvPr id="228" name="Полоса"/>
-          <p:cNvSpPr/>
-          <p:nvPr/>
-        </p:nvSpPr>
-        <p:spPr>
-          <a:xfrm>
-            <a:off x="1069848" y="8348471"/>
-            <a:ext cx="10607040" cy="914400"/>
-          </a:xfrm>
-          <a:prstGeom prst="rect">
-            <a:avLst/>
-          </a:prstGeom>
-          <a:solidFill>
-            <a:srgbClr val="F2F4F5"/>
-          </a:solidFill>
-          <a:ln>
-            <a:noFill/>
-          </a:ln>
-        </p:spPr>
-        <p:txBody>
-          <a:bodyPr rtlCol="0" anchor="ctr"/>
-          <a:lstStyle/>
-          <a:p>
-            <a:pPr algn="ctr"/>
-          </a:p>
-        </p:txBody>
-      </p:sp>
-      <p:sp>
-        <p:nvSpPr>
-          <p:cNvPr id="229" name="Компонент"/>
-          <p:cNvSpPr txBox="1"/>
-          <p:nvPr/>
-        </p:nvSpPr>
-        <p:spPr>
-          <a:xfrm>
-            <a:off x="1280160" y="8348471"/>
-            <a:ext cx="2651760" cy="914400"/>
-          </a:xfrm>
-          <a:prstGeom prst="rect">
-            <a:avLst/>
-          </a:prstGeom>
-          <a:noFill/>
-        </p:spPr>
-        <p:txBody>
-          <a:bodyPr wrap="square" anchor="ctr" lIns="0" rIns="0" tIns="0" bIns="0">
-            <a:spAutoFit/>
-          </a:bodyPr>
-          <a:lstStyle/>
-          <a:p>
-            <a:pPr algn="l"/>
-            <a:r>
-              <a:rPr sz="1700" b="1">
-                <a:solidFill>
-                  <a:srgbClr val="062D3F"/>
-                </a:solidFill>
-                <a:latin typeface="Circe Bold"/>
-              </a:rPr>
-              <a:t>Нагрузка и деградация</a:t>
-            </a:r>
-          </a:p>
-        </p:txBody>
-      </p:sp>
-      <p:sp>
-        <p:nvSpPr>
-          <p:cNvPr id="230" name="Показатели"/>
-          <p:cNvSpPr txBox="1"/>
-          <p:nvPr/>
-        </p:nvSpPr>
-        <p:spPr>
-          <a:xfrm>
-            <a:off x="4114800" y="8348471"/>
-            <a:ext cx="4206240" cy="914400"/>
-          </a:xfrm>
-          <a:prstGeom prst="rect">
-            <a:avLst/>
-          </a:prstGeom>
-          <a:noFill/>
-        </p:spPr>
-        <p:txBody>
-          <a:bodyPr wrap="square" anchor="ctr" lIns="0" rIns="0" tIns="0" bIns="0">
-            <a:spAutoFit/>
-          </a:bodyPr>
-          <a:lstStyle/>
-          <a:p>
-            <a:pPr algn="l"/>
-            <a:r>
-              <a:rPr sz="1400" b="0">
-                <a:solidFill>
-                  <a:srgbClr val="062D3F"/>
-                </a:solidFill>
-                <a:latin typeface="Circe"/>
-              </a:rPr>
-              <a:t>Доля эродированных земель, загрязнение почв и вод, опасные явления</a:t>
-            </a:r>
-          </a:p>
-        </p:txBody>
-      </p:sp>
-      <p:sp>
-        <p:nvSpPr>
-          <p:cNvPr id="231" name="Высокий уровень"/>
-          <p:cNvSpPr txBox="1"/>
-          <p:nvPr/>
-        </p:nvSpPr>
-        <p:spPr>
-          <a:xfrm>
-            <a:off x="8503920" y="8348471"/>
-            <a:ext cx="3017520" cy="914400"/>
-          </a:xfrm>
-          <a:prstGeom prst="rect">
-            <a:avLst/>
-          </a:prstGeom>
-          <a:noFill/>
-        </p:spPr>
-        <p:txBody>
-          <a:bodyPr wrap="square" anchor="ctr" lIns="0" rIns="0" tIns="0" bIns="0">
-            <a:spAutoFit/>
-          </a:bodyPr>
-          <a:lstStyle/>
-          <a:p>
-            <a:pPr algn="l"/>
-            <a:r>
-              <a:rPr sz="1400" b="0">
-                <a:solidFill>
-                  <a:srgbClr val="062D3F"/>
-                </a:solidFill>
-                <a:latin typeface="Circe"/>
-              </a:rPr>
-              <a:t>Мало эродированных земель, загрязнения и опасных явлений</a:t>
-            </a:r>
-          </a:p>
-        </p:txBody>
-      </p:sp>
-      <p:sp>
-        <p:nvSpPr>
-          <p:cNvPr id="232" name="Шапка метода"/>
-          <p:cNvSpPr/>
-          <p:nvPr/>
-        </p:nvSpPr>
-        <p:spPr>
-          <a:xfrm>
-            <a:off x="12252960" y="2331720"/>
-            <a:ext cx="5696711" cy="502920"/>
+            <a:off x="12435840" y="2331720"/>
+            <a:ext cx="5513831" cy="502920"/>
           </a:xfrm>
           <a:prstGeom prst="rect">
             <a:avLst/>
@@ -7310,20 +6937,20 @@
                 </a:solidFill>
                 <a:latin typeface="Circe Bold"/>
               </a:rPr>
-              <a:t>КАК ОЦЕНИВАТЬ</a:t>
+              <a:t>КАК СВОДЯТ В ИНДЕКС</a:t>
             </a:r>
           </a:p>
         </p:txBody>
       </p:sp>
       <p:sp>
         <p:nvSpPr>
-          <p:cNvPr id="233" name="Шаг 1"/>
+          <p:cNvPr id="222" name="Шаг 1"/>
           <p:cNvSpPr/>
           <p:nvPr/>
         </p:nvSpPr>
         <p:spPr>
           <a:xfrm>
-            <a:off x="12252960" y="3108960"/>
+            <a:off x="12435840" y="3108960"/>
             <a:ext cx="548640" cy="548640"/>
           </a:xfrm>
           <a:prstGeom prst="ellipse">
@@ -7355,14 +6982,14 @@
       </p:sp>
       <p:sp>
         <p:nvSpPr>
-          <p:cNvPr id="234" name="Шаг Сравнить"/>
+          <p:cNvPr id="223" name="Шаг Перевести в баллы"/>
           <p:cNvSpPr txBox="1"/>
           <p:nvPr/>
         </p:nvSpPr>
         <p:spPr>
           <a:xfrm>
-            <a:off x="13030200" y="3017520"/>
-            <a:ext cx="4919471" cy="1078992"/>
+            <a:off x="13213080" y="3017520"/>
+            <a:ext cx="4736592" cy="1234439"/>
           </a:xfrm>
           <a:prstGeom prst="rect">
             <a:avLst/>
@@ -7383,7 +7010,7 @@
                 </a:solidFill>
                 <a:latin typeface="Circe Bold"/>
               </a:rPr>
-              <a:t>Сравнить</a:t>
+              <a:t>Перевести в баллы</a:t>
             </a:r>
           </a:p>
           <a:p>
@@ -7399,20 +7026,20 @@
                 </a:solidFill>
                 <a:latin typeface="Circe"/>
               </a:rPr>
-              <a:t>Значение района рядом со средним по региону и с районами того же типа</a:t>
+              <a:t>Показатели переводят в ранговую шкалу от 0 до 100, максимум у района с наибольшим запасом ресурса</a:t>
             </a:r>
           </a:p>
         </p:txBody>
       </p:sp>
       <p:sp>
         <p:nvSpPr>
-          <p:cNvPr id="235" name="Шаг 2"/>
+          <p:cNvPr id="224" name="Шаг 2"/>
           <p:cNvSpPr/>
           <p:nvPr/>
         </p:nvSpPr>
         <p:spPr>
           <a:xfrm>
-            <a:off x="12252960" y="4279392"/>
+            <a:off x="12435840" y="4434840"/>
             <a:ext cx="548640" cy="548640"/>
           </a:xfrm>
           <a:prstGeom prst="ellipse">
@@ -7444,14 +7071,14 @@
       </p:sp>
       <p:sp>
         <p:nvSpPr>
-          <p:cNvPr id="236" name="Шаг Присвоить уровень"/>
+          <p:cNvPr id="225" name="Шаг Задать веса"/>
           <p:cNvSpPr txBox="1"/>
           <p:nvPr/>
         </p:nvSpPr>
         <p:spPr>
           <a:xfrm>
-            <a:off x="13030200" y="4187952"/>
-            <a:ext cx="4919471" cy="1078992"/>
+            <a:off x="13213080" y="4343400"/>
+            <a:ext cx="4736592" cy="1234439"/>
           </a:xfrm>
           <a:prstGeom prst="rect">
             <a:avLst/>
@@ -7472,7 +7099,7 @@
                 </a:solidFill>
                 <a:latin typeface="Circe Bold"/>
               </a:rPr>
-              <a:t>Присвоить уровень</a:t>
+              <a:t>Задать веса</a:t>
             </a:r>
           </a:p>
           <a:p>
@@ -7488,20 +7115,20 @@
                 </a:solidFill>
                 <a:latin typeface="Circe"/>
               </a:rPr>
-              <a:t>Высокий, средний или низкий по каждому показателю с учётом направления оценки</a:t>
+              <a:t>Вес каждого компонента определяют экспертно с учётом специализации района</a:t>
             </a:r>
           </a:p>
         </p:txBody>
       </p:sp>
       <p:sp>
         <p:nvSpPr>
-          <p:cNvPr id="237" name="Шаг 3"/>
+          <p:cNvPr id="226" name="Шаг 3"/>
           <p:cNvSpPr/>
           <p:nvPr/>
         </p:nvSpPr>
         <p:spPr>
           <a:xfrm>
-            <a:off x="12252960" y="5449824"/>
+            <a:off x="12435840" y="5760720"/>
             <a:ext cx="548640" cy="548640"/>
           </a:xfrm>
           <a:prstGeom prst="ellipse">
@@ -7533,14 +7160,14 @@
       </p:sp>
       <p:sp>
         <p:nvSpPr>
-          <p:cNvPr id="238" name="Шаг Свести по компонентам"/>
+          <p:cNvPr id="227" name="Шаг Рассчитать индекс"/>
           <p:cNvSpPr txBox="1"/>
           <p:nvPr/>
         </p:nvSpPr>
         <p:spPr>
           <a:xfrm>
-            <a:off x="13030200" y="5358384"/>
-            <a:ext cx="4919471" cy="1078992"/>
+            <a:off x="13213080" y="5669280"/>
+            <a:ext cx="4736592" cy="1234439"/>
           </a:xfrm>
           <a:prstGeom prst="rect">
             <a:avLst/>
@@ -7561,7 +7188,7 @@
                 </a:solidFill>
                 <a:latin typeface="Circe Bold"/>
               </a:rPr>
-              <a:t>Свести по компонентам</a:t>
+              <a:t>Рассчитать индекс</a:t>
             </a:r>
           </a:p>
           <a:p>
@@ -7577,20 +7204,20 @@
                 </a:solidFill>
                 <a:latin typeface="Circe"/>
               </a:rPr>
-              <a:t>Профиль потенциала и компонент, который ограничивает развитие</a:t>
+              <a:t>Интегральный индекс равен сумме баллов компонентов с учётом весов</a:t>
             </a:r>
           </a:p>
         </p:txBody>
       </p:sp>
       <p:sp>
         <p:nvSpPr>
-          <p:cNvPr id="239" name="Шаг 4"/>
+          <p:cNvPr id="228" name="Шаг 4"/>
           <p:cNvSpPr/>
           <p:nvPr/>
         </p:nvSpPr>
         <p:spPr>
           <a:xfrm>
-            <a:off x="12252960" y="6620256"/>
+            <a:off x="12435840" y="7086600"/>
             <a:ext cx="548640" cy="548640"/>
           </a:xfrm>
           <a:prstGeom prst="ellipse">
@@ -7622,14 +7249,14 @@
       </p:sp>
       <p:sp>
         <p:nvSpPr>
-          <p:cNvPr id="240" name="Шаг Передать в SWOT"/>
+          <p:cNvPr id="229" name="Шаг Найти ограничения"/>
           <p:cNvSpPr txBox="1"/>
           <p:nvPr/>
         </p:nvSpPr>
         <p:spPr>
           <a:xfrm>
-            <a:off x="13030200" y="6528816"/>
-            <a:ext cx="4919471" cy="1078992"/>
+            <a:off x="13213080" y="6995160"/>
+            <a:ext cx="4736592" cy="1234439"/>
           </a:xfrm>
           <a:prstGeom prst="rect">
             <a:avLst/>
@@ -7650,7 +7277,7 @@
                 </a:solidFill>
                 <a:latin typeface="Circe Bold"/>
               </a:rPr>
-              <a:t>Передать в SWOT</a:t>
+              <a:t>Найти ограничения</a:t>
             </a:r>
           </a:p>
           <a:p>
@@ -7666,143 +7293,21 @@
                 </a:solidFill>
                 <a:latin typeface="Circe"/>
               </a:rPr>
-              <a:t>Высокий уровень даёт сильные стороны, низкий даёт слабые</a:t>
+              <a:t>Выделяют лимитирующий компонент и сопоставляют индекс со средним по региону</a:t>
             </a:r>
           </a:p>
         </p:txBody>
       </p:sp>
       <p:sp>
         <p:nvSpPr>
-          <p:cNvPr id="241" name="Уровень ВЫСОКИЙ"/>
-          <p:cNvSpPr/>
-          <p:nvPr/>
-        </p:nvSpPr>
-        <p:spPr>
-          <a:xfrm>
-            <a:off x="12252960" y="7790688"/>
-            <a:ext cx="1807463" cy="548640"/>
-          </a:xfrm>
-          <a:prstGeom prst="roundRect">
-            <a:avLst>
-              <a:gd name="adj" fmla="val 50000"/>
-            </a:avLst>
-          </a:prstGeom>
-          <a:solidFill>
-            <a:srgbClr val="FFCC00"/>
-          </a:solidFill>
-          <a:ln>
-            <a:noFill/>
-          </a:ln>
-        </p:spPr>
-        <p:txBody>
-          <a:bodyPr rtlCol="0" anchor="ctr" wrap="square" lIns="0" rIns="0" tIns="0" bIns="0"/>
-          <a:lstStyle/>
-          <a:p>
-            <a:pPr algn="ctr"/>
-            <a:r>
-              <a:rPr sz="1400" b="1">
-                <a:solidFill>
-                  <a:srgbClr val="062D3F"/>
-                </a:solidFill>
-                <a:latin typeface="Circe Bold"/>
-              </a:rPr>
-              <a:t>ВЫСОКИЙ</a:t>
-            </a:r>
-          </a:p>
-        </p:txBody>
-      </p:sp>
-      <p:sp>
-        <p:nvSpPr>
-          <p:cNvPr id="242" name="Уровень СРЕДНИЙ"/>
-          <p:cNvSpPr/>
-          <p:nvPr/>
-        </p:nvSpPr>
-        <p:spPr>
-          <a:xfrm>
-            <a:off x="14197584" y="7790688"/>
-            <a:ext cx="1807463" cy="548640"/>
-          </a:xfrm>
-          <a:prstGeom prst="roundRect">
-            <a:avLst>
-              <a:gd name="adj" fmla="val 50000"/>
-            </a:avLst>
-          </a:prstGeom>
-          <a:solidFill>
-            <a:srgbClr val="FFF3CC"/>
-          </a:solidFill>
-          <a:ln>
-            <a:noFill/>
-          </a:ln>
-        </p:spPr>
-        <p:txBody>
-          <a:bodyPr rtlCol="0" anchor="ctr" wrap="square" lIns="0" rIns="0" tIns="0" bIns="0"/>
-          <a:lstStyle/>
-          <a:p>
-            <a:pPr algn="ctr"/>
-            <a:r>
-              <a:rPr sz="1400" b="1">
-                <a:solidFill>
-                  <a:srgbClr val="062D3F"/>
-                </a:solidFill>
-                <a:latin typeface="Circe Bold"/>
-              </a:rPr>
-              <a:t>СРЕДНИЙ</a:t>
-            </a:r>
-          </a:p>
-        </p:txBody>
-      </p:sp>
-      <p:sp>
-        <p:nvSpPr>
-          <p:cNvPr id="243" name="Уровень НИЗКИЙ"/>
-          <p:cNvSpPr/>
-          <p:nvPr/>
-        </p:nvSpPr>
-        <p:spPr>
-          <a:xfrm>
-            <a:off x="16142208" y="7790688"/>
-            <a:ext cx="1807463" cy="548640"/>
-          </a:xfrm>
-          <a:prstGeom prst="roundRect">
-            <a:avLst>
-              <a:gd name="adj" fmla="val 50000"/>
-            </a:avLst>
-          </a:prstGeom>
-          <a:solidFill>
-            <a:srgbClr val="FFFFFF"/>
-          </a:solidFill>
-          <a:ln w="19050">
-            <a:solidFill>
-              <a:srgbClr val="062D3F"/>
-            </a:solidFill>
-          </a:ln>
-        </p:spPr>
-        <p:txBody>
-          <a:bodyPr rtlCol="0" anchor="ctr" wrap="square" lIns="0" rIns="0" tIns="0" bIns="0"/>
-          <a:lstStyle/>
-          <a:p>
-            <a:pPr algn="ctr"/>
-            <a:r>
-              <a:rPr sz="1400" b="1">
-                <a:solidFill>
-                  <a:srgbClr val="062D3F"/>
-                </a:solidFill>
-                <a:latin typeface="Circe Bold"/>
-              </a:rPr>
-              <a:t>НИЗКИЙ</a:t>
-            </a:r>
-          </a:p>
-        </p:txBody>
-      </p:sp>
-      <p:sp>
-        <p:nvSpPr>
-          <p:cNvPr id="244" name="Примечание"/>
+          <p:cNvPr id="230" name="Источники"/>
           <p:cNvSpPr txBox="1"/>
           <p:nvPr/>
         </p:nvSpPr>
         <p:spPr>
           <a:xfrm>
-            <a:off x="1069848" y="9400032"/>
-            <a:ext cx="10607040" cy="502920"/>
+            <a:off x="1069848" y="8485632"/>
+            <a:ext cx="11247120" cy="640080"/>
           </a:xfrm>
           <a:prstGeom prst="rect">
             <a:avLst/>
@@ -7823,7 +7328,7 @@
                 </a:solidFill>
                 <a:latin typeface="Circe"/>
               </a:rPr>
-              <a:t>Направление оценки каждого показателя задано в таблице природных факторов. Лесистость оценивается по специализации района.</a:t>
+              <a:t>Источники. Методика оценки природно-ресурсного потенциала агроландшафтов России (журнал «Живые и биокосные системы»), материалы КГАУ по бонитировке почв, работа БГУ по оценке агроресурсного потенциала, бюллетень ИнЭкА «Россия как система» (2004). Веса и итоговую модель согласуют с заказчиком</a:t>
             </a:r>
           </a:p>
         </p:txBody>

</xml_diff>